<commit_message>
Auto sync docs/source code 2026-07-06 12:41:51
</commit_message>
<xml_diff>
--- a/综合分析/两个系统融合分析_面向AI驱动网络流量检测系统.pptx
+++ b/综合分析/两个系统融合分析_面向AI驱动网络流量检测系统.pptx
@@ -2446,13 +2446,15 @@
         </p:nvSpPr>
         <p:spPr>
           <a:xfrm>
-            <a:off x="7818120" y="45720"/>
+            <a:off x="7818120" y="109728"/>
             <a:ext cx="4297680" cy="4297680"/>
           </a:xfrm>
-          <a:prstGeom prst="arc">
-            <a:avLst/>
-          </a:prstGeom>
-          <a:noFill/>
+          <a:prstGeom prst="ellipse">
+            <a:avLst/>
+          </a:prstGeom>
+          <a:solidFill>
+            <a:srgbClr val="101820"/>
+          </a:solidFill>
           <a:ln w="25400">
             <a:solidFill>
               <a:srgbClr val="21A6A6">
@@ -2471,13 +2473,15 @@
         </p:nvSpPr>
         <p:spPr>
           <a:xfrm>
-            <a:off x="8595360" y="594360"/>
+            <a:off x="8595360" y="658368"/>
             <a:ext cx="2971800" cy="2971800"/>
           </a:xfrm>
-          <a:prstGeom prst="arc">
-            <a:avLst/>
-          </a:prstGeom>
-          <a:noFill/>
+          <a:prstGeom prst="ellipse">
+            <a:avLst/>
+          </a:prstGeom>
+          <a:solidFill>
+            <a:srgbClr val="101820"/>
+          </a:solidFill>
           <a:ln w="25400">
             <a:solidFill>
               <a:srgbClr val="B7D12A">
@@ -7218,8 +7222,10 @@
             <a:off x="685800" y="1965960"/>
             <a:ext cx="1874520" cy="1078992"/>
           </a:xfrm>
-          <a:prstGeom prst="chevron">
-            <a:avLst/>
+          <a:prstGeom prst="roundRect">
+            <a:avLst>
+              <a:gd name="adj" fmla="val 4237"/>
+            </a:avLst>
           </a:prstGeom>
           <a:solidFill>
             <a:srgbClr val="087E8B"/>
@@ -7364,8 +7370,10 @@
             <a:off x="2953512" y="1965960"/>
             <a:ext cx="1874520" cy="1078992"/>
           </a:xfrm>
-          <a:prstGeom prst="chevron">
-            <a:avLst/>
+          <a:prstGeom prst="roundRect">
+            <a:avLst>
+              <a:gd name="adj" fmla="val 4237"/>
+            </a:avLst>
           </a:prstGeom>
           <a:solidFill>
             <a:srgbClr val="2F6BFF"/>
@@ -7510,8 +7518,10 @@
             <a:off x="5221224" y="1965960"/>
             <a:ext cx="1874520" cy="1078992"/>
           </a:xfrm>
-          <a:prstGeom prst="chevron">
-            <a:avLst/>
+          <a:prstGeom prst="roundRect">
+            <a:avLst>
+              <a:gd name="adj" fmla="val 4237"/>
+            </a:avLst>
           </a:prstGeom>
           <a:solidFill>
             <a:srgbClr val="6C63FF"/>
@@ -7656,8 +7666,10 @@
             <a:off x="7488936" y="1965960"/>
             <a:ext cx="1874520" cy="1078992"/>
           </a:xfrm>
-          <a:prstGeom prst="chevron">
-            <a:avLst/>
+          <a:prstGeom prst="roundRect">
+            <a:avLst>
+              <a:gd name="adj" fmla="val 4237"/>
+            </a:avLst>
           </a:prstGeom>
           <a:solidFill>
             <a:srgbClr val="F06543"/>
@@ -7802,8 +7814,10 @@
             <a:off x="9756648" y="1965960"/>
             <a:ext cx="1874520" cy="1078992"/>
           </a:xfrm>
-          <a:prstGeom prst="chevron">
-            <a:avLst/>
+          <a:prstGeom prst="roundRect">
+            <a:avLst>
+              <a:gd name="adj" fmla="val 4237"/>
+            </a:avLst>
           </a:prstGeom>
           <a:solidFill>
             <a:srgbClr val="F5B841"/>

</xml_diff>